<commit_message>
fix: Update presentation file with new content and formatting
</commit_message>
<xml_diff>
--- a/DataStructures/Project/Presentation.pptx
+++ b/DataStructures/Project/Presentation.pptx
@@ -273,7 +273,7 @@
           <a:p>
             <a:fld id="{979E2517-0A45-47AC-AE12-896543034F76}" type="datetimeFigureOut">
               <a:rPr lang="nl-BE" smtClean="0"/>
-              <a:t>20/11/2025</a:t>
+              <a:t>28/01/2026</a:t>
             </a:fld>
             <a:endParaRPr lang="nl-BE"/>
           </a:p>
@@ -473,7 +473,7 @@
           <a:p>
             <a:fld id="{979E2517-0A45-47AC-AE12-896543034F76}" type="datetimeFigureOut">
               <a:rPr lang="nl-BE" smtClean="0"/>
-              <a:t>20/11/2025</a:t>
+              <a:t>28/01/2026</a:t>
             </a:fld>
             <a:endParaRPr lang="nl-BE"/>
           </a:p>
@@ -683,7 +683,7 @@
           <a:p>
             <a:fld id="{979E2517-0A45-47AC-AE12-896543034F76}" type="datetimeFigureOut">
               <a:rPr lang="nl-BE" smtClean="0"/>
-              <a:t>20/11/2025</a:t>
+              <a:t>28/01/2026</a:t>
             </a:fld>
             <a:endParaRPr lang="nl-BE"/>
           </a:p>
@@ -883,7 +883,7 @@
           <a:p>
             <a:fld id="{979E2517-0A45-47AC-AE12-896543034F76}" type="datetimeFigureOut">
               <a:rPr lang="nl-BE" smtClean="0"/>
-              <a:t>20/11/2025</a:t>
+              <a:t>28/01/2026</a:t>
             </a:fld>
             <a:endParaRPr lang="nl-BE"/>
           </a:p>
@@ -1159,7 +1159,7 @@
           <a:p>
             <a:fld id="{979E2517-0A45-47AC-AE12-896543034F76}" type="datetimeFigureOut">
               <a:rPr lang="nl-BE" smtClean="0"/>
-              <a:t>20/11/2025</a:t>
+              <a:t>28/01/2026</a:t>
             </a:fld>
             <a:endParaRPr lang="nl-BE"/>
           </a:p>
@@ -1427,7 +1427,7 @@
           <a:p>
             <a:fld id="{979E2517-0A45-47AC-AE12-896543034F76}" type="datetimeFigureOut">
               <a:rPr lang="nl-BE" smtClean="0"/>
-              <a:t>20/11/2025</a:t>
+              <a:t>28/01/2026</a:t>
             </a:fld>
             <a:endParaRPr lang="nl-BE"/>
           </a:p>
@@ -1842,7 +1842,7 @@
           <a:p>
             <a:fld id="{979E2517-0A45-47AC-AE12-896543034F76}" type="datetimeFigureOut">
               <a:rPr lang="nl-BE" smtClean="0"/>
-              <a:t>20/11/2025</a:t>
+              <a:t>28/01/2026</a:t>
             </a:fld>
             <a:endParaRPr lang="nl-BE"/>
           </a:p>
@@ -1984,7 +1984,7 @@
           <a:p>
             <a:fld id="{979E2517-0A45-47AC-AE12-896543034F76}" type="datetimeFigureOut">
               <a:rPr lang="nl-BE" smtClean="0"/>
-              <a:t>20/11/2025</a:t>
+              <a:t>28/01/2026</a:t>
             </a:fld>
             <a:endParaRPr lang="nl-BE"/>
           </a:p>
@@ -2097,7 +2097,7 @@
           <a:p>
             <a:fld id="{979E2517-0A45-47AC-AE12-896543034F76}" type="datetimeFigureOut">
               <a:rPr lang="nl-BE" smtClean="0"/>
-              <a:t>20/11/2025</a:t>
+              <a:t>28/01/2026</a:t>
             </a:fld>
             <a:endParaRPr lang="nl-BE"/>
           </a:p>
@@ -2410,7 +2410,7 @@
           <a:p>
             <a:fld id="{979E2517-0A45-47AC-AE12-896543034F76}" type="datetimeFigureOut">
               <a:rPr lang="nl-BE" smtClean="0"/>
-              <a:t>20/11/2025</a:t>
+              <a:t>28/01/2026</a:t>
             </a:fld>
             <a:endParaRPr lang="nl-BE"/>
           </a:p>
@@ -2703,7 +2703,7 @@
           <a:p>
             <a:fld id="{979E2517-0A45-47AC-AE12-896543034F76}" type="datetimeFigureOut">
               <a:rPr lang="nl-BE" smtClean="0"/>
-              <a:t>20/11/2025</a:t>
+              <a:t>28/01/2026</a:t>
             </a:fld>
             <a:endParaRPr lang="nl-BE"/>
           </a:p>
@@ -2946,7 +2946,7 @@
           <a:p>
             <a:fld id="{979E2517-0A45-47AC-AE12-896543034F76}" type="datetimeFigureOut">
               <a:rPr lang="nl-BE" smtClean="0"/>
-              <a:t>20/11/2025</a:t>
+              <a:t>28/01/2026</a:t>
             </a:fld>
             <a:endParaRPr lang="nl-BE"/>
           </a:p>
@@ -4139,7 +4139,7 @@
               <a:t> A </a:t>
             </a:r>
             <a:r>
-              <a:rPr lang="nl-BE" sz="2000" dirty="0" err="1">
+              <a:rPr lang="nl-BE" sz="2000" b="1" dirty="0" err="1">
                 <a:solidFill>
                   <a:srgbClr val="4F94F0"/>
                 </a:solidFill>
@@ -4149,6 +4149,16 @@
               <a:t>sparse</a:t>
             </a:r>
             <a:r>
+              <a:rPr lang="nl-BE" sz="2000" b="1" dirty="0">
+                <a:solidFill>
+                  <a:srgbClr val="4F94F0"/>
+                </a:solidFill>
+                <a:latin typeface="Arial" panose="020B0604020202020204" pitchFamily="34" charset="0"/>
+                <a:cs typeface="Arial" panose="020B0604020202020204" pitchFamily="34" charset="0"/>
+              </a:rPr>
+              <a:t> matrix</a:t>
+            </a:r>
+            <a:r>
               <a:rPr lang="nl-BE" sz="2000" dirty="0">
                 <a:solidFill>
                   <a:srgbClr val="4F94F0"/>
@@ -4156,7 +4166,7 @@
                 <a:latin typeface="Arial" panose="020B0604020202020204" pitchFamily="34" charset="0"/>
                 <a:cs typeface="Arial" panose="020B0604020202020204" pitchFamily="34" charset="0"/>
               </a:rPr>
-              <a:t> matrix.</a:t>
+              <a:t>.</a:t>
             </a:r>
           </a:p>
           <a:p>
@@ -4181,7 +4191,27 @@
                 <a:latin typeface="Arial" panose="020B0604020202020204" pitchFamily="34" charset="0"/>
                 <a:cs typeface="Arial" panose="020B0604020202020204" pitchFamily="34" charset="0"/>
               </a:rPr>
-              <a:t>We use a simple Map structure (COO format) to store only the non-zero numbers.</a:t>
+              <a:t>We use a simple Map structure (</a:t>
+            </a:r>
+            <a:r>
+              <a:rPr lang="en-US" sz="2000" b="1" dirty="0">
+                <a:solidFill>
+                  <a:srgbClr val="4F94F0"/>
+                </a:solidFill>
+                <a:latin typeface="Arial" panose="020B0604020202020204" pitchFamily="34" charset="0"/>
+                <a:cs typeface="Arial" panose="020B0604020202020204" pitchFamily="34" charset="0"/>
+              </a:rPr>
+              <a:t>COO</a:t>
+            </a:r>
+            <a:r>
+              <a:rPr lang="en-US" sz="2000" dirty="0">
+                <a:solidFill>
+                  <a:srgbClr val="4F94F0"/>
+                </a:solidFill>
+                <a:latin typeface="Arial" panose="020B0604020202020204" pitchFamily="34" charset="0"/>
+                <a:cs typeface="Arial" panose="020B0604020202020204" pitchFamily="34" charset="0"/>
+              </a:rPr>
+              <a:t> format) to store only the non-zero numbers.</a:t>
             </a:r>
           </a:p>
           <a:p>
@@ -4206,7 +4236,27 @@
                 <a:latin typeface="Arial" panose="020B0604020202020204" pitchFamily="34" charset="0"/>
                 <a:cs typeface="Arial" panose="020B0604020202020204" pitchFamily="34" charset="0"/>
               </a:rPr>
-              <a:t>All required unit tests passed, proving the system is correct and saves memory.</a:t>
+              <a:t>All required unit </a:t>
+            </a:r>
+            <a:r>
+              <a:rPr lang="en-US" sz="2000" b="1" dirty="0">
+                <a:solidFill>
+                  <a:srgbClr val="4F94F0"/>
+                </a:solidFill>
+                <a:latin typeface="Arial" panose="020B0604020202020204" pitchFamily="34" charset="0"/>
+                <a:cs typeface="Arial" panose="020B0604020202020204" pitchFamily="34" charset="0"/>
+              </a:rPr>
+              <a:t>tests</a:t>
+            </a:r>
+            <a:r>
+              <a:rPr lang="en-US" sz="2000" dirty="0">
+                <a:solidFill>
+                  <a:srgbClr val="4F94F0"/>
+                </a:solidFill>
+                <a:latin typeface="Arial" panose="020B0604020202020204" pitchFamily="34" charset="0"/>
+                <a:cs typeface="Arial" panose="020B0604020202020204" pitchFamily="34" charset="0"/>
+              </a:rPr>
+              <a:t> passed, proving the system is correct and saves memory.</a:t>
             </a:r>
           </a:p>
           <a:p>

</xml_diff>